<commit_message>
List all seven presenters on the thank-you slide
</commit_message>
<xml_diff>
--- a/final_20_slides.pptx
+++ b/final_20_slides.pptx
@@ -5552,8 +5552,8 @@
         </p:nvSpPr>
         <p:spPr>
           <a:xfrm>
-            <a:off x="914400" y="1554480"/>
-            <a:ext cx="7315200" cy="914400"/>
+            <a:off x="914400" y="868680"/>
+            <a:ext cx="7315200" cy="822960"/>
           </a:xfrm>
           <a:prstGeom prst="rect">
             <a:avLst/>
@@ -5591,7 +5591,7 @@
         </p:nvSpPr>
         <p:spPr>
           <a:xfrm>
-            <a:off x="914400" y="2514600"/>
+            <a:off x="914400" y="1737360"/>
             <a:ext cx="7315200" cy="365760"/>
           </a:xfrm>
           <a:prstGeom prst="rect">
@@ -5655,7 +5655,7 @@
                 <a:ea typeface="Calibri" pitchFamily="34" charset="-122"/>
                 <a:cs typeface="Calibri" pitchFamily="34" charset="-120"/>
               </a:rPr>
-              <a:t>Priyansh Agrawal  |  Roll No. 23120073  |  Metallurgical and Materials Engineering, NIT Raipur</a:t>
+              <a:t>Department of Metallurgical and Materials Engineering, NIT Raipur</a:t>
             </a:r>
             <a:endParaRPr lang="en-US" sz="1200" dirty="0"/>
           </a:p>
@@ -5697,6 +5697,437 @@
               <a:t>With thanks to Mr. Shikhar Tiwary and the BRM team, Bhilai Steel Plant</a:t>
             </a:r>
             <a:endParaRPr lang="en-US" sz="1200" dirty="0"/>
+          </a:p>
+        </p:txBody>
+      </p:sp>
+      <p:sp>
+        <p:nvSpPr>
+          <p:cNvPr id="7" name="Text 7"/>
+          <p:cNvSpPr txBox="1"/>
+          <p:nvPr/>
+        </p:nvSpPr>
+        <p:spPr>
+          <a:xfrm>
+            <a:off x="914400" y="2423160"/>
+            <a:ext cx="3657600" cy="228600"/>
+          </a:xfrm>
+          <a:prstGeom prst="rect">
+            <a:avLst/>
+          </a:prstGeom>
+          <a:noFill/>
+          <a:ln/>
+        </p:spPr>
+        <p:txBody>
+          <a:bodyPr wrap="square" lIns="0" tIns="0" rIns="0" bIns="0" rtlCol="0" anchor="ctr"/>
+          <a:lstStyle/>
+          <a:p>
+            <a:pPr marL="0" indent="0">
+              <a:buNone/>
+            </a:pPr>
+            <a:r>
+              <a:rPr lang="en-US" sz="1000" b="1" kern="0" spc="200" dirty="0">
+                <a:solidFill>
+                  <a:srgbClr val="C8553D"/>
+                </a:solidFill>
+                <a:latin typeface="Calibri" pitchFamily="34" charset="0"/>
+                <a:ea typeface="Calibri" pitchFamily="34" charset="-122"/>
+                <a:cs typeface="Calibri" pitchFamily="34" charset="-120"/>
+              </a:rPr>
+              <a:t>PRESENTED BY</a:t>
+            </a:r>
+            <a:endParaRPr lang="en-US" sz="1000" dirty="0"/>
+          </a:p>
+        </p:txBody>
+      </p:sp>
+      <p:sp>
+        <p:nvSpPr>
+          <p:cNvPr id="8" name="Text 8"/>
+          <p:cNvSpPr txBox="1"/>
+          <p:nvPr/>
+        </p:nvSpPr>
+        <p:spPr>
+          <a:xfrm>
+            <a:off x="914400" y="2743200"/>
+            <a:ext cx="1828800" cy="502920"/>
+          </a:xfrm>
+          <a:prstGeom prst="rect">
+            <a:avLst/>
+          </a:prstGeom>
+          <a:noFill/>
+          <a:ln/>
+        </p:spPr>
+        <p:txBody>
+          <a:bodyPr wrap="square" lIns="0" tIns="0" rIns="0" bIns="0" rtlCol="0" anchor="t"/>
+          <a:lstStyle/>
+          <a:p>
+            <a:pPr marL="0" indent="0">
+              <a:buNone/>
+            </a:pPr>
+            <a:r>
+              <a:rPr lang="en-US" sz="1300" b="1" dirty="0">
+                <a:solidFill>
+                  <a:srgbClr val="1B3A5C"/>
+                </a:solidFill>
+                <a:latin typeface="Calibri" pitchFamily="34" charset="0"/>
+                <a:ea typeface="Calibri" pitchFamily="34" charset="-122"/>
+                <a:cs typeface="Calibri" pitchFamily="34" charset="-120"/>
+              </a:rPr>
+              <a:t>Anshika Pandey</a:t>
+            </a:r>
+            <a:endParaRPr lang="en-US" sz="1300" dirty="0"/>
+          </a:p>
+          <a:p>
+            <a:pPr marL="0" indent="0">
+              <a:buNone/>
+            </a:pPr>
+            <a:r>
+              <a:rPr lang="en-US" sz="1050" dirty="0">
+                <a:solidFill>
+                  <a:srgbClr val="6B7280"/>
+                </a:solidFill>
+                <a:latin typeface="Calibri" pitchFamily="34" charset="0"/>
+                <a:ea typeface="Calibri" pitchFamily="34" charset="-122"/>
+                <a:cs typeface="Calibri" pitchFamily="34" charset="-120"/>
+              </a:rPr>
+              <a:t>23120016</a:t>
+            </a:r>
+            <a:endParaRPr lang="en-US" sz="1050" dirty="0"/>
+          </a:p>
+        </p:txBody>
+      </p:sp>
+      <p:sp>
+        <p:nvSpPr>
+          <p:cNvPr id="9" name="Text 9"/>
+          <p:cNvSpPr txBox="1"/>
+          <p:nvPr/>
+        </p:nvSpPr>
+        <p:spPr>
+          <a:xfrm>
+            <a:off x="2834640" y="2743200"/>
+            <a:ext cx="1828800" cy="502920"/>
+          </a:xfrm>
+          <a:prstGeom prst="rect">
+            <a:avLst/>
+          </a:prstGeom>
+          <a:noFill/>
+          <a:ln/>
+        </p:spPr>
+        <p:txBody>
+          <a:bodyPr wrap="square" lIns="0" tIns="0" rIns="0" bIns="0" rtlCol="0" anchor="t"/>
+          <a:lstStyle/>
+          <a:p>
+            <a:pPr marL="0" indent="0">
+              <a:buNone/>
+            </a:pPr>
+            <a:r>
+              <a:rPr lang="en-US" sz="1300" b="1" dirty="0">
+                <a:solidFill>
+                  <a:srgbClr val="1B3A5C"/>
+                </a:solidFill>
+                <a:latin typeface="Calibri" pitchFamily="34" charset="0"/>
+                <a:ea typeface="Calibri" pitchFamily="34" charset="-122"/>
+                <a:cs typeface="Calibri" pitchFamily="34" charset="-120"/>
+              </a:rPr>
+              <a:t>Naval Deshpande</a:t>
+            </a:r>
+            <a:endParaRPr lang="en-US" sz="1300" dirty="0"/>
+          </a:p>
+          <a:p>
+            <a:pPr marL="0" indent="0">
+              <a:buNone/>
+            </a:pPr>
+            <a:r>
+              <a:rPr lang="en-US" sz="1050" dirty="0">
+                <a:solidFill>
+                  <a:srgbClr val="6B7280"/>
+                </a:solidFill>
+                <a:latin typeface="Calibri" pitchFamily="34" charset="0"/>
+                <a:ea typeface="Calibri" pitchFamily="34" charset="-122"/>
+                <a:cs typeface="Calibri" pitchFamily="34" charset="-120"/>
+              </a:rPr>
+              <a:t>23120053</a:t>
+            </a:r>
+            <a:endParaRPr lang="en-US" sz="1050" dirty="0"/>
+          </a:p>
+        </p:txBody>
+      </p:sp>
+      <p:sp>
+        <p:nvSpPr>
+          <p:cNvPr id="10" name="Text 10"/>
+          <p:cNvSpPr txBox="1"/>
+          <p:nvPr/>
+        </p:nvSpPr>
+        <p:spPr>
+          <a:xfrm>
+            <a:off x="4754880" y="2743200"/>
+            <a:ext cx="1828800" cy="502920"/>
+          </a:xfrm>
+          <a:prstGeom prst="rect">
+            <a:avLst/>
+          </a:prstGeom>
+          <a:noFill/>
+          <a:ln/>
+        </p:spPr>
+        <p:txBody>
+          <a:bodyPr wrap="square" lIns="0" tIns="0" rIns="0" bIns="0" rtlCol="0" anchor="t"/>
+          <a:lstStyle/>
+          <a:p>
+            <a:pPr marL="0" indent="0">
+              <a:buNone/>
+            </a:pPr>
+            <a:r>
+              <a:rPr lang="en-US" sz="1300" b="1" dirty="0">
+                <a:solidFill>
+                  <a:srgbClr val="1B3A5C"/>
+                </a:solidFill>
+                <a:latin typeface="Calibri" pitchFamily="34" charset="0"/>
+                <a:ea typeface="Calibri" pitchFamily="34" charset="-122"/>
+                <a:cs typeface="Calibri" pitchFamily="34" charset="-120"/>
+              </a:rPr>
+              <a:t>Ojas Pandey</a:t>
+            </a:r>
+            <a:endParaRPr lang="en-US" sz="1300" dirty="0"/>
+          </a:p>
+          <a:p>
+            <a:pPr marL="0" indent="0">
+              <a:buNone/>
+            </a:pPr>
+            <a:r>
+              <a:rPr lang="en-US" sz="1050" dirty="0">
+                <a:solidFill>
+                  <a:srgbClr val="6B7280"/>
+                </a:solidFill>
+                <a:latin typeface="Calibri" pitchFamily="34" charset="0"/>
+                <a:ea typeface="Calibri" pitchFamily="34" charset="-122"/>
+                <a:cs typeface="Calibri" pitchFamily="34" charset="-120"/>
+              </a:rPr>
+              <a:t>23120059</a:t>
+            </a:r>
+            <a:endParaRPr lang="en-US" sz="1050" dirty="0"/>
+          </a:p>
+        </p:txBody>
+      </p:sp>
+      <p:sp>
+        <p:nvSpPr>
+          <p:cNvPr id="11" name="Text 11"/>
+          <p:cNvSpPr txBox="1"/>
+          <p:nvPr/>
+        </p:nvSpPr>
+        <p:spPr>
+          <a:xfrm>
+            <a:off x="6675120" y="2743200"/>
+            <a:ext cx="1828800" cy="502920"/>
+          </a:xfrm>
+          <a:prstGeom prst="rect">
+            <a:avLst/>
+          </a:prstGeom>
+          <a:noFill/>
+          <a:ln/>
+        </p:spPr>
+        <p:txBody>
+          <a:bodyPr wrap="square" lIns="0" tIns="0" rIns="0" bIns="0" rtlCol="0" anchor="t"/>
+          <a:lstStyle/>
+          <a:p>
+            <a:pPr marL="0" indent="0">
+              <a:buNone/>
+            </a:pPr>
+            <a:r>
+              <a:rPr lang="en-US" sz="1300" b="1" dirty="0">
+                <a:solidFill>
+                  <a:srgbClr val="1B3A5C"/>
+                </a:solidFill>
+                <a:latin typeface="Calibri" pitchFamily="34" charset="0"/>
+                <a:ea typeface="Calibri" pitchFamily="34" charset="-122"/>
+                <a:cs typeface="Calibri" pitchFamily="34" charset="-120"/>
+              </a:rPr>
+              <a:t>Chirag Singhal</a:t>
+            </a:r>
+            <a:endParaRPr lang="en-US" sz="1300" dirty="0"/>
+          </a:p>
+          <a:p>
+            <a:pPr marL="0" indent="0">
+              <a:buNone/>
+            </a:pPr>
+            <a:r>
+              <a:rPr lang="en-US" sz="1050" dirty="0">
+                <a:solidFill>
+                  <a:srgbClr val="6B7280"/>
+                </a:solidFill>
+                <a:latin typeface="Calibri" pitchFamily="34" charset="0"/>
+                <a:ea typeface="Calibri" pitchFamily="34" charset="-122"/>
+                <a:cs typeface="Calibri" pitchFamily="34" charset="-120"/>
+              </a:rPr>
+              <a:t>23120031</a:t>
+            </a:r>
+            <a:endParaRPr lang="en-US" sz="1050" dirty="0"/>
+          </a:p>
+        </p:txBody>
+      </p:sp>
+      <p:sp>
+        <p:nvSpPr>
+          <p:cNvPr id="12" name="Text 12"/>
+          <p:cNvSpPr txBox="1"/>
+          <p:nvPr/>
+        </p:nvSpPr>
+        <p:spPr>
+          <a:xfrm>
+            <a:off x="914400" y="3291840"/>
+            <a:ext cx="1828800" cy="502920"/>
+          </a:xfrm>
+          <a:prstGeom prst="rect">
+            <a:avLst/>
+          </a:prstGeom>
+          <a:noFill/>
+          <a:ln/>
+        </p:spPr>
+        <p:txBody>
+          <a:bodyPr wrap="square" lIns="0" tIns="0" rIns="0" bIns="0" rtlCol="0" anchor="t"/>
+          <a:lstStyle/>
+          <a:p>
+            <a:pPr marL="0" indent="0">
+              <a:buNone/>
+            </a:pPr>
+            <a:r>
+              <a:rPr lang="en-US" sz="1300" b="1" dirty="0">
+                <a:solidFill>
+                  <a:srgbClr val="1B3A5C"/>
+                </a:solidFill>
+                <a:latin typeface="Calibri" pitchFamily="34" charset="0"/>
+                <a:ea typeface="Calibri" pitchFamily="34" charset="-122"/>
+                <a:cs typeface="Calibri" pitchFamily="34" charset="-120"/>
+              </a:rPr>
+              <a:t>Om Agrawal</a:t>
+            </a:r>
+            <a:endParaRPr lang="en-US" sz="1300" dirty="0"/>
+          </a:p>
+          <a:p>
+            <a:pPr marL="0" indent="0">
+              <a:buNone/>
+            </a:pPr>
+            <a:r>
+              <a:rPr lang="en-US" sz="1050" dirty="0">
+                <a:solidFill>
+                  <a:srgbClr val="6B7280"/>
+                </a:solidFill>
+                <a:latin typeface="Calibri" pitchFamily="34" charset="0"/>
+                <a:ea typeface="Calibri" pitchFamily="34" charset="-122"/>
+                <a:cs typeface="Calibri" pitchFamily="34" charset="-120"/>
+              </a:rPr>
+              <a:t>23120060</a:t>
+            </a:r>
+            <a:endParaRPr lang="en-US" sz="1050" dirty="0"/>
+          </a:p>
+        </p:txBody>
+      </p:sp>
+      <p:sp>
+        <p:nvSpPr>
+          <p:cNvPr id="13" name="Text 13"/>
+          <p:cNvSpPr txBox="1"/>
+          <p:nvPr/>
+        </p:nvSpPr>
+        <p:spPr>
+          <a:xfrm>
+            <a:off x="2834640" y="3291840"/>
+            <a:ext cx="1828800" cy="502920"/>
+          </a:xfrm>
+          <a:prstGeom prst="rect">
+            <a:avLst/>
+          </a:prstGeom>
+          <a:noFill/>
+          <a:ln/>
+        </p:spPr>
+        <p:txBody>
+          <a:bodyPr wrap="square" lIns="0" tIns="0" rIns="0" bIns="0" rtlCol="0" anchor="t"/>
+          <a:lstStyle/>
+          <a:p>
+            <a:pPr marL="0" indent="0">
+              <a:buNone/>
+            </a:pPr>
+            <a:r>
+              <a:rPr lang="en-US" sz="1300" b="1" dirty="0">
+                <a:solidFill>
+                  <a:srgbClr val="1B3A5C"/>
+                </a:solidFill>
+                <a:latin typeface="Calibri" pitchFamily="34" charset="0"/>
+                <a:ea typeface="Calibri" pitchFamily="34" charset="-122"/>
+                <a:cs typeface="Calibri" pitchFamily="34" charset="-120"/>
+              </a:rPr>
+              <a:t>Priyansh Agrawal</a:t>
+            </a:r>
+            <a:endParaRPr lang="en-US" sz="1300" dirty="0"/>
+          </a:p>
+          <a:p>
+            <a:pPr marL="0" indent="0">
+              <a:buNone/>
+            </a:pPr>
+            <a:r>
+              <a:rPr lang="en-US" sz="1050" dirty="0">
+                <a:solidFill>
+                  <a:srgbClr val="6B7280"/>
+                </a:solidFill>
+                <a:latin typeface="Calibri" pitchFamily="34" charset="0"/>
+                <a:ea typeface="Calibri" pitchFamily="34" charset="-122"/>
+                <a:cs typeface="Calibri" pitchFamily="34" charset="-120"/>
+              </a:rPr>
+              <a:t>23120073</a:t>
+            </a:r>
+            <a:endParaRPr lang="en-US" sz="1050" dirty="0"/>
+          </a:p>
+        </p:txBody>
+      </p:sp>
+      <p:sp>
+        <p:nvSpPr>
+          <p:cNvPr id="14" name="Text 14"/>
+          <p:cNvSpPr txBox="1"/>
+          <p:nvPr/>
+        </p:nvSpPr>
+        <p:spPr>
+          <a:xfrm>
+            <a:off x="4754880" y="3291840"/>
+            <a:ext cx="1828800" cy="502920"/>
+          </a:xfrm>
+          <a:prstGeom prst="rect">
+            <a:avLst/>
+          </a:prstGeom>
+          <a:noFill/>
+          <a:ln/>
+        </p:spPr>
+        <p:txBody>
+          <a:bodyPr wrap="square" lIns="0" tIns="0" rIns="0" bIns="0" rtlCol="0" anchor="t"/>
+          <a:lstStyle/>
+          <a:p>
+            <a:pPr marL="0" indent="0">
+              <a:buNone/>
+            </a:pPr>
+            <a:r>
+              <a:rPr lang="en-US" sz="1300" b="1" dirty="0">
+                <a:solidFill>
+                  <a:srgbClr val="1B3A5C"/>
+                </a:solidFill>
+                <a:latin typeface="Calibri" pitchFamily="34" charset="0"/>
+                <a:ea typeface="Calibri" pitchFamily="34" charset="-122"/>
+                <a:cs typeface="Calibri" pitchFamily="34" charset="-120"/>
+              </a:rPr>
+              <a:t>Siddharth Jha</a:t>
+            </a:r>
+            <a:endParaRPr lang="en-US" sz="1300" dirty="0"/>
+          </a:p>
+          <a:p>
+            <a:pPr marL="0" indent="0">
+              <a:buNone/>
+            </a:pPr>
+            <a:r>
+              <a:rPr lang="en-US" sz="1050" dirty="0">
+                <a:solidFill>
+                  <a:srgbClr val="6B7280"/>
+                </a:solidFill>
+                <a:latin typeface="Calibri" pitchFamily="34" charset="0"/>
+                <a:ea typeface="Calibri" pitchFamily="34" charset="-122"/>
+                <a:cs typeface="Calibri" pitchFamily="34" charset="-120"/>
+              </a:rPr>
+              <a:t>23120095</a:t>
+            </a:r>
+            <a:endParaRPr lang="en-US" sz="1050" dirty="0"/>
           </a:p>
         </p:txBody>
       </p:sp>

</xml_diff>